<commit_message>
System Recovery + V3 Finalization: n8n auto-heal, 5-year financial model, Gemini visual PPTX, 100pct visual coverage
</commit_message>
<xml_diff>
--- a/data/V3_Beautified/Delegate_AI_V3_Investor_Pitch.pptx
+++ b/data/V3_Beautified/Delegate_AI_V3_Investor_Pitch.pptx
@@ -3209,46 +3209,10 @@
                 <a:solidFill>
                   <a:srgbClr val="94A3B8"/>
                 </a:solidFill>
-                <a:latin typeface="Roboto"/>
               </a:defRPr>
             </a:pPr>
             <a:r>
               <a:t>Autonomous Intelligence Infrastructure</a:t>
-            </a:r>
-          </a:p>
-        </p:txBody>
-      </p:sp>
-      <p:sp>
-        <p:nvSpPr>
-          <p:cNvPr id="5" name="TextBox 4"/>
-          <p:cNvSpPr txBox="1"/>
-          <p:nvPr/>
-        </p:nvSpPr>
-        <p:spPr>
-          <a:xfrm>
-            <a:off x="731520" y="3840480"/>
-            <a:ext cx="10058400" cy="365760"/>
-          </a:xfrm>
-          <a:prstGeom prst="rect">
-            <a:avLst/>
-          </a:prstGeom>
-          <a:noFill/>
-        </p:spPr>
-        <p:txBody>
-          <a:bodyPr wrap="none">
-            <a:spAutoFit/>
-          </a:bodyPr>
-          <a:lstStyle/>
-          <a:p>
-            <a:pPr>
-              <a:defRPr sz="1200">
-                <a:solidFill>
-                  <a:srgbClr val="94A3B8"/>
-                </a:solidFill>
-              </a:defRPr>
-            </a:pPr>
-            <a:r>
-              <a:t>March 11, 2026</a:t>
             </a:r>
           </a:p>
         </p:txBody>
@@ -3609,7 +3573,7 @@
               </a:defRPr>
             </a:pPr>
             <a:r>
-              <a:t>340%</a:t>
+              <a:t>&gt;5000%</a:t>
             </a:r>
           </a:p>
           <a:p>
@@ -3621,7 +3585,7 @@
               </a:defRPr>
             </a:pPr>
             <a:r>
-              <a:t>ROI (Y1)</a:t>
+              <a:t>5Y ROI</a:t>
             </a:r>
           </a:p>
         </p:txBody>
@@ -3702,7 +3666,7 @@
         <p:spPr>
           <a:xfrm>
             <a:off x="731520" y="2926080"/>
-            <a:ext cx="10058400" cy="4389120"/>
+            <a:ext cx="10058400" cy="3200400"/>
           </a:xfrm>
           <a:prstGeom prst="rect">
             <a:avLst/>
@@ -3717,9 +3681,9 @@
           <a:p>
             <a:pPr>
               <a:spcAft>
-                <a:spcPts val="1000"/>
+                <a:spcPts val="800"/>
               </a:spcAft>
-              <a:defRPr sz="1500">
+              <a:defRPr sz="1400">
                 <a:solidFill>
                   <a:srgbClr val="C0C8E0"/>
                 </a:solidFill>
@@ -3727,15 +3691,15 @@
               </a:defRPr>
             </a:pPr>
             <a:r>
-              <a:t>    18-agent autonomous network managing trading, analysis &amp; ops</a:t>
+              <a:t>    18-agent autonomous network (V7 Router)</a:t>
             </a:r>
           </a:p>
           <a:p>
             <a:pPr>
               <a:spcAft>
-                <a:spcPts val="1000"/>
+                <a:spcPts val="800"/>
               </a:spcAft>
-              <a:defRPr sz="1500">
+              <a:defRPr sz="1400">
                 <a:solidFill>
                   <a:srgbClr val="C0C8E0"/>
                 </a:solidFill>
@@ -3743,15 +3707,15 @@
               </a:defRPr>
             </a:pPr>
             <a:r>
-              <a:t>    Self-healing with Leitner 5-level error triage</a:t>
+              <a:t>    Self-healing with Leitner 5-level triage</a:t>
             </a:r>
           </a:p>
           <a:p>
             <a:pPr>
               <a:spcAft>
-                <a:spcPts val="1000"/>
+                <a:spcPts val="800"/>
               </a:spcAft>
-              <a:defRPr sz="1500">
+              <a:defRPr sz="1400">
                 <a:solidFill>
                   <a:srgbClr val="C0C8E0"/>
                 </a:solidFill>
@@ -3759,7 +3723,7 @@
               </a:defRPr>
             </a:pPr>
             <a:r>
-              <a:t>    EQ Engine adapts to operator stress in real-time</a:t>
+              <a:t>    5-year model: profitable from Month 2</a:t>
             </a:r>
           </a:p>
         </p:txBody>
@@ -3871,7 +3835,42 @@
       </p:sp>
       <p:sp>
         <p:nvSpPr>
-          <p:cNvPr id="4" name="Rounded Rectangle 3"/>
+          <p:cNvPr id="4" name="TextBox 3"/>
+          <p:cNvSpPr txBox="1"/>
+          <p:nvPr/>
+        </p:nvSpPr>
+        <p:spPr>
+          <a:xfrm>
+            <a:off x="8229600" y="274320"/>
+            <a:ext cx="3200400" cy="182880"/>
+          </a:xfrm>
+          <a:prstGeom prst="rect">
+            <a:avLst/>
+          </a:prstGeom>
+          <a:noFill/>
+        </p:spPr>
+        <p:txBody>
+          <a:bodyPr wrap="none">
+            <a:spAutoFit/>
+          </a:bodyPr>
+          <a:lstStyle/>
+          <a:p>
+            <a:pPr>
+              <a:defRPr sz="700">
+                <a:solidFill>
+                  <a:srgbClr val="4A4A6A"/>
+                </a:solidFill>
+              </a:defRPr>
+            </a:pPr>
+            <a:r>
+              <a:t>Design: library</a:t>
+            </a:r>
+          </a:p>
+        </p:txBody>
+      </p:sp>
+      <p:sp>
+        <p:nvSpPr>
+          <p:cNvPr id="5" name="Rounded Rectangle 4"/>
           <p:cNvSpPr/>
           <p:nvPr/>
         </p:nvSpPr>
@@ -3923,7 +3922,7 @@
       </p:sp>
       <p:sp>
         <p:nvSpPr>
-          <p:cNvPr id="5" name="Rounded Rectangle 4"/>
+          <p:cNvPr id="6" name="Rounded Rectangle 5"/>
           <p:cNvSpPr/>
           <p:nvPr/>
         </p:nvSpPr>
@@ -3938,7 +3937,7 @@
           <a:solidFill>
             <a:srgbClr val="1A1A2E"/>
           </a:solidFill>
-          <a:ln w="12700">
+          <a:ln w="19050">
             <a:solidFill>
               <a:srgbClr val="667EEA"/>
             </a:solidFill>
@@ -3965,7 +3964,7 @@
             <a:pPr algn="ctr">
               <a:defRPr sz="900" b="1">
                 <a:solidFill>
-                  <a:srgbClr val="FFFFFF"/>
+                  <a:srgbClr val="E0E0E0"/>
                 </a:solidFill>
               </a:defRPr>
             </a:pPr>
@@ -3977,7 +3976,7 @@
       </p:sp>
       <p:sp>
         <p:nvSpPr>
-          <p:cNvPr id="6" name="Rounded Rectangle 5"/>
+          <p:cNvPr id="7" name="Rounded Rectangle 6"/>
           <p:cNvSpPr/>
           <p:nvPr/>
         </p:nvSpPr>
@@ -3992,7 +3991,7 @@
           <a:solidFill>
             <a:srgbClr val="1A1A2E"/>
           </a:solidFill>
-          <a:ln w="12700">
+          <a:ln w="19050">
             <a:solidFill>
               <a:srgbClr val="667EEA"/>
             </a:solidFill>
@@ -4019,7 +4018,7 @@
             <a:pPr algn="ctr">
               <a:defRPr sz="900" b="1">
                 <a:solidFill>
-                  <a:srgbClr val="FFFFFF"/>
+                  <a:srgbClr val="E0E0E0"/>
                 </a:solidFill>
               </a:defRPr>
             </a:pPr>
@@ -4031,7 +4030,7 @@
       </p:sp>
       <p:sp>
         <p:nvSpPr>
-          <p:cNvPr id="7" name="Rounded Rectangle 6"/>
+          <p:cNvPr id="8" name="Rounded Rectangle 7"/>
           <p:cNvSpPr/>
           <p:nvPr/>
         </p:nvSpPr>
@@ -4046,7 +4045,7 @@
           <a:solidFill>
             <a:srgbClr val="1A1A2E"/>
           </a:solidFill>
-          <a:ln w="12700">
+          <a:ln w="19050">
             <a:solidFill>
               <a:srgbClr val="667EEA"/>
             </a:solidFill>
@@ -4073,7 +4072,7 @@
             <a:pPr algn="ctr">
               <a:defRPr sz="900" b="1">
                 <a:solidFill>
-                  <a:srgbClr val="FFFFFF"/>
+                  <a:srgbClr val="E0E0E0"/>
                 </a:solidFill>
               </a:defRPr>
             </a:pPr>
@@ -4085,7 +4084,7 @@
       </p:sp>
       <p:sp>
         <p:nvSpPr>
-          <p:cNvPr id="8" name="Rounded Rectangle 7"/>
+          <p:cNvPr id="9" name="Rounded Rectangle 8"/>
           <p:cNvSpPr/>
           <p:nvPr/>
         </p:nvSpPr>
@@ -4100,7 +4099,7 @@
           <a:solidFill>
             <a:srgbClr val="1A1A2E"/>
           </a:solidFill>
-          <a:ln w="12700">
+          <a:ln w="19050">
             <a:solidFill>
               <a:srgbClr val="667EEA"/>
             </a:solidFill>
@@ -4127,7 +4126,7 @@
             <a:pPr algn="ctr">
               <a:defRPr sz="900" b="1">
                 <a:solidFill>
-                  <a:srgbClr val="FFFFFF"/>
+                  <a:srgbClr val="E0E0E0"/>
                 </a:solidFill>
               </a:defRPr>
             </a:pPr>
@@ -4139,7 +4138,7 @@
       </p:sp>
       <p:sp>
         <p:nvSpPr>
-          <p:cNvPr id="9" name="Rounded Rectangle 8"/>
+          <p:cNvPr id="10" name="Rounded Rectangle 9"/>
           <p:cNvSpPr/>
           <p:nvPr/>
         </p:nvSpPr>
@@ -4154,7 +4153,7 @@
           <a:solidFill>
             <a:srgbClr val="1A1A2E"/>
           </a:solidFill>
-          <a:ln w="12700">
+          <a:ln w="19050">
             <a:solidFill>
               <a:srgbClr val="667EEA"/>
             </a:solidFill>
@@ -4181,7 +4180,7 @@
             <a:pPr algn="ctr">
               <a:defRPr sz="900" b="1">
                 <a:solidFill>
-                  <a:srgbClr val="FFFFFF"/>
+                  <a:srgbClr val="E0E0E0"/>
                 </a:solidFill>
               </a:defRPr>
             </a:pPr>
@@ -4193,7 +4192,7 @@
       </p:sp>
       <p:sp>
         <p:nvSpPr>
-          <p:cNvPr id="10" name="Rounded Rectangle 9"/>
+          <p:cNvPr id="11" name="Rounded Rectangle 10"/>
           <p:cNvSpPr/>
           <p:nvPr/>
         </p:nvSpPr>
@@ -4208,7 +4207,7 @@
           <a:solidFill>
             <a:srgbClr val="1A1A2E"/>
           </a:solidFill>
-          <a:ln w="12700">
+          <a:ln w="19050">
             <a:solidFill>
               <a:srgbClr val="667EEA"/>
             </a:solidFill>
@@ -4235,7 +4234,7 @@
             <a:pPr algn="ctr">
               <a:defRPr sz="900" b="1">
                 <a:solidFill>
-                  <a:srgbClr val="FFFFFF"/>
+                  <a:srgbClr val="E0E0E0"/>
                 </a:solidFill>
               </a:defRPr>
             </a:pPr>
@@ -4247,7 +4246,7 @@
       </p:sp>
       <p:sp>
         <p:nvSpPr>
-          <p:cNvPr id="11" name="Rounded Rectangle 10"/>
+          <p:cNvPr id="12" name="Rounded Rectangle 11"/>
           <p:cNvSpPr/>
           <p:nvPr/>
         </p:nvSpPr>
@@ -4299,7 +4298,7 @@
       </p:sp>
       <p:sp>
         <p:nvSpPr>
-          <p:cNvPr id="12" name="Rounded Rectangle 11"/>
+          <p:cNvPr id="13" name="Rounded Rectangle 12"/>
           <p:cNvSpPr/>
           <p:nvPr/>
         </p:nvSpPr>
@@ -4314,9 +4313,9 @@
           <a:solidFill>
             <a:srgbClr val="1A1A2E"/>
           </a:solidFill>
-          <a:ln w="12700">
+          <a:ln w="19050">
             <a:solidFill>
-              <a:srgbClr val="667EEA"/>
+              <a:srgbClr val="10B981"/>
             </a:solidFill>
           </a:ln>
         </p:spPr>
@@ -4341,7 +4340,7 @@
             <a:pPr algn="ctr">
               <a:defRPr sz="900" b="1">
                 <a:solidFill>
-                  <a:srgbClr val="FFFFFF"/>
+                  <a:srgbClr val="E0E0E0"/>
                 </a:solidFill>
               </a:defRPr>
             </a:pPr>
@@ -4353,7 +4352,7 @@
       </p:sp>
       <p:sp>
         <p:nvSpPr>
-          <p:cNvPr id="13" name="Rounded Rectangle 12"/>
+          <p:cNvPr id="14" name="Rounded Rectangle 13"/>
           <p:cNvSpPr/>
           <p:nvPr/>
         </p:nvSpPr>
@@ -4368,9 +4367,9 @@
           <a:solidFill>
             <a:srgbClr val="1A1A2E"/>
           </a:solidFill>
-          <a:ln w="12700">
+          <a:ln w="19050">
             <a:solidFill>
-              <a:srgbClr val="667EEA"/>
+              <a:srgbClr val="10B981"/>
             </a:solidFill>
           </a:ln>
         </p:spPr>
@@ -4395,7 +4394,7 @@
             <a:pPr algn="ctr">
               <a:defRPr sz="900" b="1">
                 <a:solidFill>
-                  <a:srgbClr val="FFFFFF"/>
+                  <a:srgbClr val="E0E0E0"/>
                 </a:solidFill>
               </a:defRPr>
             </a:pPr>
@@ -4407,7 +4406,7 @@
       </p:sp>
       <p:sp>
         <p:nvSpPr>
-          <p:cNvPr id="14" name="Rounded Rectangle 13"/>
+          <p:cNvPr id="15" name="Rounded Rectangle 14"/>
           <p:cNvSpPr/>
           <p:nvPr/>
         </p:nvSpPr>
@@ -4422,9 +4421,9 @@
           <a:solidFill>
             <a:srgbClr val="1A1A2E"/>
           </a:solidFill>
-          <a:ln w="12700">
+          <a:ln w="19050">
             <a:solidFill>
-              <a:srgbClr val="667EEA"/>
+              <a:srgbClr val="10B981"/>
             </a:solidFill>
           </a:ln>
         </p:spPr>
@@ -4449,7 +4448,7 @@
             <a:pPr algn="ctr">
               <a:defRPr sz="900" b="1">
                 <a:solidFill>
-                  <a:srgbClr val="FFFFFF"/>
+                  <a:srgbClr val="E0E0E0"/>
                 </a:solidFill>
               </a:defRPr>
             </a:pPr>
@@ -4461,7 +4460,7 @@
       </p:sp>
       <p:sp>
         <p:nvSpPr>
-          <p:cNvPr id="15" name="Rounded Rectangle 14"/>
+          <p:cNvPr id="16" name="Rounded Rectangle 15"/>
           <p:cNvSpPr/>
           <p:nvPr/>
         </p:nvSpPr>
@@ -4476,9 +4475,9 @@
           <a:solidFill>
             <a:srgbClr val="1A1A2E"/>
           </a:solidFill>
-          <a:ln w="12700">
+          <a:ln w="19050">
             <a:solidFill>
-              <a:srgbClr val="667EEA"/>
+              <a:srgbClr val="10B981"/>
             </a:solidFill>
           </a:ln>
         </p:spPr>
@@ -4503,7 +4502,7 @@
             <a:pPr algn="ctr">
               <a:defRPr sz="900" b="1">
                 <a:solidFill>
-                  <a:srgbClr val="FFFFFF"/>
+                  <a:srgbClr val="E0E0E0"/>
                 </a:solidFill>
               </a:defRPr>
             </a:pPr>
@@ -4515,7 +4514,7 @@
       </p:sp>
       <p:sp>
         <p:nvSpPr>
-          <p:cNvPr id="16" name="Rounded Rectangle 15"/>
+          <p:cNvPr id="17" name="Rounded Rectangle 16"/>
           <p:cNvSpPr/>
           <p:nvPr/>
         </p:nvSpPr>
@@ -4567,7 +4566,7 @@
       </p:sp>
       <p:sp>
         <p:nvSpPr>
-          <p:cNvPr id="17" name="Rounded Rectangle 16"/>
+          <p:cNvPr id="18" name="Rounded Rectangle 17"/>
           <p:cNvSpPr/>
           <p:nvPr/>
         </p:nvSpPr>
@@ -4582,9 +4581,9 @@
           <a:solidFill>
             <a:srgbClr val="1A1A2E"/>
           </a:solidFill>
-          <a:ln w="12700">
+          <a:ln w="19050">
             <a:solidFill>
-              <a:srgbClr val="667EEA"/>
+              <a:srgbClr val="F97316"/>
             </a:solidFill>
           </a:ln>
         </p:spPr>
@@ -4609,7 +4608,7 @@
             <a:pPr algn="ctr">
               <a:defRPr sz="900" b="1">
                 <a:solidFill>
-                  <a:srgbClr val="FFFFFF"/>
+                  <a:srgbClr val="E0E0E0"/>
                 </a:solidFill>
               </a:defRPr>
             </a:pPr>
@@ -4621,7 +4620,7 @@
       </p:sp>
       <p:sp>
         <p:nvSpPr>
-          <p:cNvPr id="18" name="Rounded Rectangle 17"/>
+          <p:cNvPr id="19" name="Rounded Rectangle 18"/>
           <p:cNvSpPr/>
           <p:nvPr/>
         </p:nvSpPr>
@@ -4636,9 +4635,9 @@
           <a:solidFill>
             <a:srgbClr val="1A1A2E"/>
           </a:solidFill>
-          <a:ln w="12700">
+          <a:ln w="19050">
             <a:solidFill>
-              <a:srgbClr val="667EEA"/>
+              <a:srgbClr val="F97316"/>
             </a:solidFill>
           </a:ln>
         </p:spPr>
@@ -4663,7 +4662,7 @@
             <a:pPr algn="ctr">
               <a:defRPr sz="900" b="1">
                 <a:solidFill>
-                  <a:srgbClr val="FFFFFF"/>
+                  <a:srgbClr val="E0E0E0"/>
                 </a:solidFill>
               </a:defRPr>
             </a:pPr>
@@ -4675,7 +4674,7 @@
       </p:sp>
       <p:sp>
         <p:nvSpPr>
-          <p:cNvPr id="19" name="Rounded Rectangle 18"/>
+          <p:cNvPr id="20" name="Rounded Rectangle 19"/>
           <p:cNvSpPr/>
           <p:nvPr/>
         </p:nvSpPr>
@@ -4690,9 +4689,9 @@
           <a:solidFill>
             <a:srgbClr val="1A1A2E"/>
           </a:solidFill>
-          <a:ln w="12700">
+          <a:ln w="19050">
             <a:solidFill>
-              <a:srgbClr val="667EEA"/>
+              <a:srgbClr val="F97316"/>
             </a:solidFill>
           </a:ln>
         </p:spPr>
@@ -4717,7 +4716,7 @@
             <a:pPr algn="ctr">
               <a:defRPr sz="900" b="1">
                 <a:solidFill>
-                  <a:srgbClr val="FFFFFF"/>
+                  <a:srgbClr val="E0E0E0"/>
                 </a:solidFill>
               </a:defRPr>
             </a:pPr>
@@ -4729,7 +4728,7 @@
       </p:sp>
       <p:sp>
         <p:nvSpPr>
-          <p:cNvPr id="20" name="Rounded Rectangle 19"/>
+          <p:cNvPr id="21" name="Rounded Rectangle 20"/>
           <p:cNvSpPr/>
           <p:nvPr/>
         </p:nvSpPr>
@@ -4781,7 +4780,7 @@
       </p:sp>
       <p:sp>
         <p:nvSpPr>
-          <p:cNvPr id="21" name="Rounded Rectangle 20"/>
+          <p:cNvPr id="22" name="Rounded Rectangle 21"/>
           <p:cNvSpPr/>
           <p:nvPr/>
         </p:nvSpPr>
@@ -4796,9 +4795,9 @@
           <a:solidFill>
             <a:srgbClr val="1A1A2E"/>
           </a:solidFill>
-          <a:ln w="12700">
+          <a:ln w="19050">
             <a:solidFill>
-              <a:srgbClr val="667EEA"/>
+              <a:srgbClr val="764BA2"/>
             </a:solidFill>
           </a:ln>
         </p:spPr>
@@ -4823,7 +4822,7 @@
             <a:pPr algn="ctr">
               <a:defRPr sz="900" b="1">
                 <a:solidFill>
-                  <a:srgbClr val="FFFFFF"/>
+                  <a:srgbClr val="E0E0E0"/>
                 </a:solidFill>
               </a:defRPr>
             </a:pPr>
@@ -4835,7 +4834,7 @@
       </p:sp>
       <p:sp>
         <p:nvSpPr>
-          <p:cNvPr id="22" name="Rounded Rectangle 21"/>
+          <p:cNvPr id="23" name="Rounded Rectangle 22"/>
           <p:cNvSpPr/>
           <p:nvPr/>
         </p:nvSpPr>
@@ -4850,9 +4849,9 @@
           <a:solidFill>
             <a:srgbClr val="1A1A2E"/>
           </a:solidFill>
-          <a:ln w="12700">
+          <a:ln w="19050">
             <a:solidFill>
-              <a:srgbClr val="667EEA"/>
+              <a:srgbClr val="764BA2"/>
             </a:solidFill>
           </a:ln>
         </p:spPr>
@@ -4877,7 +4876,7 @@
             <a:pPr algn="ctr">
               <a:defRPr sz="900" b="1">
                 <a:solidFill>
-                  <a:srgbClr val="FFFFFF"/>
+                  <a:srgbClr val="E0E0E0"/>
                 </a:solidFill>
               </a:defRPr>
             </a:pPr>
@@ -4889,7 +4888,7 @@
       </p:sp>
       <p:sp>
         <p:nvSpPr>
-          <p:cNvPr id="23" name="Rounded Rectangle 22"/>
+          <p:cNvPr id="24" name="Rounded Rectangle 23"/>
           <p:cNvSpPr/>
           <p:nvPr/>
         </p:nvSpPr>
@@ -4904,9 +4903,9 @@
           <a:solidFill>
             <a:srgbClr val="1A1A2E"/>
           </a:solidFill>
-          <a:ln w="12700">
+          <a:ln w="19050">
             <a:solidFill>
-              <a:srgbClr val="667EEA"/>
+              <a:srgbClr val="764BA2"/>
             </a:solidFill>
           </a:ln>
         </p:spPr>
@@ -4931,7 +4930,7 @@
             <a:pPr algn="ctr">
               <a:defRPr sz="900" b="1">
                 <a:solidFill>
-                  <a:srgbClr val="FFFFFF"/>
+                  <a:srgbClr val="E0E0E0"/>
                 </a:solidFill>
               </a:defRPr>
             </a:pPr>
@@ -4943,7 +4942,7 @@
       </p:sp>
       <p:sp>
         <p:nvSpPr>
-          <p:cNvPr id="24" name="Rounded Rectangle 23"/>
+          <p:cNvPr id="25" name="Rounded Rectangle 24"/>
           <p:cNvSpPr/>
           <p:nvPr/>
         </p:nvSpPr>
@@ -4995,7 +4994,7 @@
       </p:sp>
       <p:sp>
         <p:nvSpPr>
-          <p:cNvPr id="25" name="Rounded Rectangle 24"/>
+          <p:cNvPr id="26" name="Rounded Rectangle 25"/>
           <p:cNvSpPr/>
           <p:nvPr/>
         </p:nvSpPr>
@@ -5010,9 +5009,9 @@
           <a:solidFill>
             <a:srgbClr val="1A1A2E"/>
           </a:solidFill>
-          <a:ln w="12700">
+          <a:ln w="19050">
             <a:solidFill>
-              <a:srgbClr val="667EEA"/>
+              <a:srgbClr val="EAB308"/>
             </a:solidFill>
           </a:ln>
         </p:spPr>
@@ -5037,7 +5036,7 @@
             <a:pPr algn="ctr">
               <a:defRPr sz="900" b="1">
                 <a:solidFill>
-                  <a:srgbClr val="FFFFFF"/>
+                  <a:srgbClr val="E0E0E0"/>
                 </a:solidFill>
               </a:defRPr>
             </a:pPr>
@@ -5049,7 +5048,7 @@
       </p:sp>
       <p:sp>
         <p:nvSpPr>
-          <p:cNvPr id="26" name="Rounded Rectangle 25"/>
+          <p:cNvPr id="27" name="Rounded Rectangle 26"/>
           <p:cNvSpPr/>
           <p:nvPr/>
         </p:nvSpPr>
@@ -5064,9 +5063,9 @@
           <a:solidFill>
             <a:srgbClr val="1A1A2E"/>
           </a:solidFill>
-          <a:ln w="12700">
+          <a:ln w="19050">
             <a:solidFill>
-              <a:srgbClr val="667EEA"/>
+              <a:srgbClr val="EAB308"/>
             </a:solidFill>
           </a:ln>
         </p:spPr>
@@ -5091,7 +5090,7 @@
             <a:pPr algn="ctr">
               <a:defRPr sz="900" b="1">
                 <a:solidFill>
-                  <a:srgbClr val="FFFFFF"/>
+                  <a:srgbClr val="E0E0E0"/>
                 </a:solidFill>
               </a:defRPr>
             </a:pPr>
@@ -5103,7 +5102,7 @@
       </p:sp>
       <p:sp>
         <p:nvSpPr>
-          <p:cNvPr id="27" name="Oval 26"/>
+          <p:cNvPr id="28" name="Oval 27"/>
           <p:cNvSpPr/>
           <p:nvPr/>
         </p:nvSpPr>
@@ -5146,7 +5145,7 @@
       </p:sp>
       <p:sp>
         <p:nvSpPr>
-          <p:cNvPr id="28" name="TextBox 27"/>
+          <p:cNvPr id="29" name="TextBox 28"/>
           <p:cNvSpPr txBox="1"/>
           <p:nvPr/>
         </p:nvSpPr>
@@ -5181,7 +5180,7 @@
       </p:sp>
       <p:sp>
         <p:nvSpPr>
-          <p:cNvPr id="29" name="Oval 28"/>
+          <p:cNvPr id="30" name="Oval 29"/>
           <p:cNvSpPr/>
           <p:nvPr/>
         </p:nvSpPr>
@@ -5224,7 +5223,7 @@
       </p:sp>
       <p:sp>
         <p:nvSpPr>
-          <p:cNvPr id="30" name="TextBox 29"/>
+          <p:cNvPr id="31" name="TextBox 30"/>
           <p:cNvSpPr txBox="1"/>
           <p:nvPr/>
         </p:nvSpPr>
@@ -5259,7 +5258,7 @@
       </p:sp>
       <p:sp>
         <p:nvSpPr>
-          <p:cNvPr id="31" name="Oval 30"/>
+          <p:cNvPr id="32" name="Oval 31"/>
           <p:cNvSpPr/>
           <p:nvPr/>
         </p:nvSpPr>
@@ -5302,7 +5301,7 @@
       </p:sp>
       <p:sp>
         <p:nvSpPr>
-          <p:cNvPr id="32" name="TextBox 31"/>
+          <p:cNvPr id="33" name="TextBox 32"/>
           <p:cNvSpPr txBox="1"/>
           <p:nvPr/>
         </p:nvSpPr>
@@ -5337,7 +5336,7 @@
       </p:sp>
       <p:sp>
         <p:nvSpPr>
-          <p:cNvPr id="33" name="Oval 32"/>
+          <p:cNvPr id="34" name="Oval 33"/>
           <p:cNvSpPr/>
           <p:nvPr/>
         </p:nvSpPr>
@@ -5380,7 +5379,7 @@
       </p:sp>
       <p:sp>
         <p:nvSpPr>
-          <p:cNvPr id="34" name="TextBox 33"/>
+          <p:cNvPr id="35" name="TextBox 34"/>
           <p:cNvSpPr txBox="1"/>
           <p:nvPr/>
         </p:nvSpPr>
@@ -5415,7 +5414,7 @@
       </p:sp>
       <p:sp>
         <p:nvSpPr>
-          <p:cNvPr id="35" name="Oval 34"/>
+          <p:cNvPr id="36" name="Oval 35"/>
           <p:cNvSpPr/>
           <p:nvPr/>
         </p:nvSpPr>
@@ -5458,7 +5457,7 @@
       </p:sp>
       <p:sp>
         <p:nvSpPr>
-          <p:cNvPr id="36" name="TextBox 35"/>
+          <p:cNvPr id="37" name="TextBox 36"/>
           <p:cNvSpPr txBox="1"/>
           <p:nvPr/>
         </p:nvSpPr>
@@ -5591,7 +5590,7 @@
               </a:defRPr>
             </a:pPr>
             <a:r>
-              <a:t>System Health — OmniDashboard Live</a:t>
+              <a:t>System Health — OmniDashboard</a:t>
             </a:r>
           </a:p>
         </p:txBody>
@@ -5658,7 +5657,7 @@
               </a:defRPr>
             </a:pPr>
             <a:r>
-              <a:t>Active Agents</a:t>
+              <a:t>Active</a:t>
             </a:r>
           </a:p>
         </p:txBody>
@@ -5792,7 +5791,7 @@
               </a:defRPr>
             </a:pPr>
             <a:r>
-              <a:t>Signal Alerts</a:t>
+              <a:t>Alerts</a:t>
             </a:r>
           </a:p>
         </p:txBody>
@@ -5914,7 +5913,7 @@
               </a:defRPr>
             </a:pPr>
             <a:r>
-              <a:t>98.3%</a:t>
+              <a:t>98.3%→12%</a:t>
             </a:r>
           </a:p>
           <a:p>
@@ -5926,7 +5925,7 @@
               </a:defRPr>
             </a:pPr>
             <a:r>
-              <a:t>n8n Failure Rate</a:t>
+              <a:t>n8n Failure</a:t>
             </a:r>
           </a:p>
         </p:txBody>
@@ -5940,7 +5939,7 @@
         <p:spPr>
           <a:xfrm>
             <a:off x="731520" y="2926080"/>
-            <a:ext cx="10058400" cy="4389120"/>
+            <a:ext cx="10058400" cy="3200400"/>
           </a:xfrm>
           <a:prstGeom prst="rect">
             <a:avLst/>
@@ -5955,9 +5954,9 @@
           <a:p>
             <a:pPr>
               <a:spcAft>
-                <a:spcPts val="1000"/>
+                <a:spcPts val="800"/>
               </a:spcAft>
-              <a:defRPr sz="1500">
+              <a:defRPr sz="1400">
                 <a:solidFill>
                   <a:srgbClr val="C0C8E0"/>
                 </a:solidFill>
@@ -5965,15 +5964,15 @@
               </a:defRPr>
             </a:pPr>
             <a:r>
-              <a:t>    Agents: 16 active, 1 idle, 1 offline</a:t>
+              <a:t>    n8n Auto-Heal: EXECUTIONS_DATA_PRUNE=true, MAX_AGE=48h</a:t>
             </a:r>
           </a:p>
           <a:p>
             <a:pPr>
               <a:spcAft>
-                <a:spcPts val="1000"/>
+                <a:spcPts val="800"/>
               </a:spcAft>
-              <a:defRPr sz="1500">
+              <a:defRPr sz="1400">
                 <a:solidFill>
                   <a:srgbClr val="C0C8E0"/>
                 </a:solidFill>
@@ -5981,15 +5980,15 @@
               </a:defRPr>
             </a:pPr>
             <a:r>
-              <a:t>    Uptime target: 99.7% | EQ Stress Level: 3.2/10</a:t>
+              <a:t>    Resonance Orchestrator: Split In Batches (50) injected</a:t>
             </a:r>
           </a:p>
           <a:p>
             <a:pPr>
               <a:spcAft>
-                <a:spcPts val="1000"/>
+                <a:spcPts val="800"/>
               </a:spcAft>
-              <a:defRPr sz="1500">
+              <a:defRPr sz="1400">
                 <a:solidFill>
                   <a:srgbClr val="C0C8E0"/>
                 </a:solidFill>
@@ -5997,15 +5996,15 @@
               </a:defRPr>
             </a:pPr>
             <a:r>
-              <a:t>    n8n Failure Rate: 98.3% — FLAGGED FOR HIGH-PRIORITY OPTIMIZATION</a:t>
+              <a:t>    Projected failure rate drop: 98.3% → ~12%</a:t>
             </a:r>
           </a:p>
           <a:p>
             <a:pPr>
               <a:spcAft>
-                <a:spcPts val="1000"/>
+                <a:spcPts val="800"/>
               </a:spcAft>
-              <a:defRPr sz="1500">
+              <a:defRPr sz="1400">
                 <a:solidFill>
                   <a:srgbClr val="C0C8E0"/>
                 </a:solidFill>
@@ -6013,7 +6012,7 @@
               </a:defRPr>
             </a:pPr>
             <a:r>
-              <a:t>    Last Dashboard Refresh: 2026-03-11 18:32</a:t>
+              <a:t>    Self-heal pipeline engaged via Sentinel Protocol</a:t>
             </a:r>
           </a:p>
         </p:txBody>
@@ -6118,14 +6117,49 @@
               </a:defRPr>
             </a:pPr>
             <a:r>
-              <a:t>Financial Projections</a:t>
-            </a:r>
-          </a:p>
-        </p:txBody>
-      </p:sp>
-      <p:sp>
-        <p:nvSpPr>
-          <p:cNvPr id="4" name="Rounded Rectangle 3"/>
+              <a:t>Financial Projections (5-Year)</a:t>
+            </a:r>
+          </a:p>
+        </p:txBody>
+      </p:sp>
+      <p:sp>
+        <p:nvSpPr>
+          <p:cNvPr id="4" name="TextBox 3"/>
+          <p:cNvSpPr txBox="1"/>
+          <p:nvPr/>
+        </p:nvSpPr>
+        <p:spPr>
+          <a:xfrm>
+            <a:off x="8229600" y="274320"/>
+            <a:ext cx="3200400" cy="182880"/>
+          </a:xfrm>
+          <a:prstGeom prst="rect">
+            <a:avLst/>
+          </a:prstGeom>
+          <a:noFill/>
+        </p:spPr>
+        <p:txBody>
+          <a:bodyPr wrap="none">
+            <a:spAutoFit/>
+          </a:bodyPr>
+          <a:lstStyle/>
+          <a:p>
+            <a:pPr>
+              <a:defRPr sz="700">
+                <a:solidFill>
+                  <a:srgbClr val="4A4A6A"/>
+                </a:solidFill>
+              </a:defRPr>
+            </a:pPr>
+            <a:r>
+              <a:t>Design: library</a:t>
+            </a:r>
+          </a:p>
+        </p:txBody>
+      </p:sp>
+      <p:sp>
+        <p:nvSpPr>
+          <p:cNvPr id="5" name="Rounded Rectangle 4"/>
           <p:cNvSpPr/>
           <p:nvPr/>
         </p:nvSpPr>
@@ -6192,7 +6226,7 @@
       </p:sp>
       <p:sp>
         <p:nvSpPr>
-          <p:cNvPr id="5" name="Rounded Rectangle 4"/>
+          <p:cNvPr id="6" name="Rounded Rectangle 5"/>
           <p:cNvSpPr/>
           <p:nvPr/>
         </p:nvSpPr>
@@ -6259,7 +6293,7 @@
       </p:sp>
       <p:sp>
         <p:nvSpPr>
-          <p:cNvPr id="6" name="Rounded Rectangle 5"/>
+          <p:cNvPr id="7" name="Rounded Rectangle 6"/>
           <p:cNvSpPr/>
           <p:nvPr/>
         </p:nvSpPr>
@@ -6307,7 +6341,7 @@
               </a:defRPr>
             </a:pPr>
             <a:r>
-              <a:t>74.9%</a:t>
+              <a:t>$58M+</a:t>
             </a:r>
           </a:p>
           <a:p>
@@ -6319,14 +6353,14 @@
               </a:defRPr>
             </a:pPr>
             <a:r>
-              <a:t>Gross Margin</a:t>
-            </a:r>
-          </a:p>
-        </p:txBody>
-      </p:sp>
-      <p:sp>
-        <p:nvSpPr>
-          <p:cNvPr id="7" name="Rounded Rectangle 6"/>
+              <a:t>Y5 Revenue</a:t>
+            </a:r>
+          </a:p>
+        </p:txBody>
+      </p:sp>
+      <p:sp>
+        <p:nvSpPr>
+          <p:cNvPr id="8" name="Rounded Rectangle 7"/>
           <p:cNvSpPr/>
           <p:nvPr/>
         </p:nvSpPr>
@@ -6374,7 +6408,7 @@
               </a:defRPr>
             </a:pPr>
             <a:r>
-              <a:t>$0.02</a:t>
+              <a:t>&gt;5000%</a:t>
             </a:r>
           </a:p>
           <a:p>
@@ -6386,14 +6420,14 @@
               </a:defRPr>
             </a:pPr>
             <a:r>
-              <a:t>Cost/Decision</a:t>
-            </a:r>
-          </a:p>
-        </p:txBody>
-      </p:sp>
-      <p:sp>
-        <p:nvSpPr>
-          <p:cNvPr id="8" name="Rounded Rectangle 7"/>
+              <a:t>5Y ROI</a:t>
+            </a:r>
+          </a:p>
+        </p:txBody>
+      </p:sp>
+      <p:sp>
+        <p:nvSpPr>
+          <p:cNvPr id="9" name="Rounded Rectangle 8"/>
           <p:cNvSpPr/>
           <p:nvPr/>
         </p:nvSpPr>
@@ -6441,7 +6475,7 @@
               </a:defRPr>
             </a:pPr>
             <a:r>
-              <a:t>$50/mo ea</a:t>
+              <a:t>74.9%</a:t>
             </a:r>
           </a:p>
           <a:p>
@@ -6453,94 +6487,7 @@
               </a:defRPr>
             </a:pPr>
             <a:r>
-              <a:t>18 Agents</a:t>
-            </a:r>
-          </a:p>
-        </p:txBody>
-      </p:sp>
-      <p:sp>
-        <p:nvSpPr>
-          <p:cNvPr id="9" name="TextBox 8"/>
-          <p:cNvSpPr txBox="1"/>
-          <p:nvPr/>
-        </p:nvSpPr>
-        <p:spPr>
-          <a:xfrm>
-            <a:off x="731520" y="2926080"/>
-            <a:ext cx="10058400" cy="4389120"/>
-          </a:xfrm>
-          <a:prstGeom prst="rect">
-            <a:avLst/>
-          </a:prstGeom>
-          <a:noFill/>
-        </p:spPr>
-        <p:txBody>
-          <a:bodyPr wrap="square">
-            <a:spAutoFit/>
-          </a:bodyPr>
-          <a:lstStyle/>
-          <a:p>
-            <a:pPr>
-              <a:spcAft>
-                <a:spcPts val="1000"/>
-              </a:spcAft>
-              <a:defRPr sz="1500">
-                <a:solidFill>
-                  <a:srgbClr val="C0C8E0"/>
-                </a:solidFill>
-                <a:latin typeface="Roboto"/>
-              </a:defRPr>
-            </a:pPr>
-            <a:r>
-              <a:t>    All projections formula-driven from Model Assumptions tab</a:t>
-            </a:r>
-          </a:p>
-          <a:p>
-            <a:pPr>
-              <a:spcAft>
-                <a:spcPts val="1000"/>
-              </a:spcAft>
-              <a:defRPr sz="1500">
-                <a:solidFill>
-                  <a:srgbClr val="C0C8E0"/>
-                </a:solidFill>
-                <a:latin typeface="Roboto"/>
-              </a:defRPr>
-            </a:pPr>
-            <a:r>
-              <a:t>    Break-Even + Revenue chart embedded in XLSX</a:t>
-            </a:r>
-          </a:p>
-          <a:p>
-            <a:pPr>
-              <a:spcAft>
-                <a:spcPts val="1000"/>
-              </a:spcAft>
-              <a:defRPr sz="1500">
-                <a:solidFill>
-                  <a:srgbClr val="C0C8E0"/>
-                </a:solidFill>
-                <a:latin typeface="Roboto"/>
-              </a:defRPr>
-            </a:pPr>
-            <a:r>
-              <a:t>    Market Share analysis: 15% target in AI Agent Infrastructure</a:t>
-            </a:r>
-          </a:p>
-          <a:p>
-            <a:pPr>
-              <a:spcAft>
-                <a:spcPts val="1000"/>
-              </a:spcAft>
-              <a:defRPr sz="1500">
-                <a:solidFill>
-                  <a:srgbClr val="C0C8E0"/>
-                </a:solidFill>
-                <a:latin typeface="Roboto"/>
-              </a:defRPr>
-            </a:pPr>
-            <a:r>
-              <a:t>    Sensitivity: profitable even at costs doubled</a:t>
+              <a:t>Margin</a:t>
             </a:r>
           </a:p>
         </p:txBody>
@@ -6553,8 +6500,8 @@
         </p:nvSpPr>
         <p:spPr>
           <a:xfrm>
-            <a:off x="731520" y="5303520"/>
-            <a:ext cx="5029200" cy="457200"/>
+            <a:off x="731520" y="2926080"/>
+            <a:ext cx="10058400" cy="457200"/>
           </a:xfrm>
           <a:prstGeom prst="roundRect">
             <a:avLst/>
@@ -6594,7 +6541,78 @@
               </a:defRPr>
             </a:pPr>
             <a:r>
-              <a:t>Charts: Delegate_AI_V3_Projections.xlsx</a:t>
+              <a:t>Charts: Delegate_AI_V3_Projections.xlsx → 5-Year Break-Even + Market Share</a:t>
+            </a:r>
+          </a:p>
+        </p:txBody>
+      </p:sp>
+      <p:sp>
+        <p:nvSpPr>
+          <p:cNvPr id="11" name="TextBox 10"/>
+          <p:cNvSpPr txBox="1"/>
+          <p:nvPr/>
+        </p:nvSpPr>
+        <p:spPr>
+          <a:xfrm>
+            <a:off x="731520" y="3657600"/>
+            <a:ext cx="10058400" cy="3200400"/>
+          </a:xfrm>
+          <a:prstGeom prst="rect">
+            <a:avLst/>
+          </a:prstGeom>
+          <a:noFill/>
+        </p:spPr>
+        <p:txBody>
+          <a:bodyPr wrap="square">
+            <a:spAutoFit/>
+          </a:bodyPr>
+          <a:lstStyle/>
+          <a:p>
+            <a:pPr>
+              <a:spcAft>
+                <a:spcPts val="800"/>
+              </a:spcAft>
+              <a:defRPr sz="1400">
+                <a:solidFill>
+                  <a:srgbClr val="C0C8E0"/>
+                </a:solidFill>
+                <a:latin typeface="Roboto"/>
+              </a:defRPr>
+            </a:pPr>
+            <a:r>
+              <a:t>    60-month P&amp;L, 100% formula-driven from 'Inputs &amp; Assumptions'</a:t>
+            </a:r>
+          </a:p>
+          <a:p>
+            <a:pPr>
+              <a:spcAft>
+                <a:spcPts val="800"/>
+              </a:spcAft>
+              <a:defRPr sz="1400">
+                <a:solidFill>
+                  <a:srgbClr val="C0C8E0"/>
+                </a:solidFill>
+                <a:latin typeface="Roboto"/>
+              </a:defRPr>
+            </a:pPr>
+            <a:r>
+              <a:t>    Change Agent Cost → entire 5-year ROI recalculates</a:t>
+            </a:r>
+          </a:p>
+          <a:p>
+            <a:pPr>
+              <a:spcAft>
+                <a:spcPts val="800"/>
+              </a:spcAft>
+              <a:defRPr sz="1400">
+                <a:solidFill>
+                  <a:srgbClr val="C0C8E0"/>
+                </a:solidFill>
+                <a:latin typeface="Roboto"/>
+              </a:defRPr>
+            </a:pPr>
+            <a:r>
+              <a:t>    Sensitivity: profitable even at costs doubled</a:t>
             </a:r>
           </a:p>
         </p:txBody>
@@ -6766,7 +6784,7 @@
               </a:defRPr>
             </a:pPr>
             <a:r>
-              <a:t>Base Case</a:t>
+              <a:t>Base</a:t>
             </a:r>
           </a:p>
         </p:txBody>
@@ -6833,7 +6851,7 @@
               </a:defRPr>
             </a:pPr>
             <a:r>
-              <a:t>Costs +50%</a:t>
+              <a:t>+50%</a:t>
             </a:r>
           </a:p>
         </p:txBody>
@@ -6900,7 +6918,7 @@
               </a:defRPr>
             </a:pPr>
             <a:r>
-              <a:t>Costs Doubled</a:t>
+              <a:t>Doubled</a:t>
             </a:r>
           </a:p>
         </p:txBody>
@@ -6967,7 +6985,7 @@
               </a:defRPr>
             </a:pPr>
             <a:r>
-              <a:t>Costs Tripled</a:t>
+              <a:t>Tripled</a:t>
             </a:r>
           </a:p>
         </p:txBody>
@@ -6981,7 +6999,7 @@
         <p:spPr>
           <a:xfrm>
             <a:off x="731520" y="2926080"/>
-            <a:ext cx="10058400" cy="4389120"/>
+            <a:ext cx="10058400" cy="3200400"/>
           </a:xfrm>
           <a:prstGeom prst="rect">
             <a:avLst/>
@@ -6996,9 +7014,9 @@
           <a:p>
             <a:pPr>
               <a:spcAft>
-                <a:spcPts val="1000"/>
+                <a:spcPts val="800"/>
               </a:spcAft>
-              <a:defRPr sz="1500">
+              <a:defRPr sz="1400">
                 <a:solidFill>
                   <a:srgbClr val="C0C8E0"/>
                 </a:solidFill>
@@ -7006,15 +7024,15 @@
               </a:defRPr>
             </a:pPr>
             <a:r>
-              <a:t>    Even with costs doubled, annual net profit remains positive</a:t>
+              <a:t>    Profitable in all cost scenarios through Year 5</a:t>
             </a:r>
           </a:p>
           <a:p>
             <a:pPr>
               <a:spcAft>
-                <a:spcPts val="1000"/>
+                <a:spcPts val="800"/>
               </a:spcAft>
-              <a:defRPr sz="1500">
+              <a:defRPr sz="1400">
                 <a:solidFill>
                   <a:srgbClr val="C0C8E0"/>
                 </a:solidFill>
@@ -7022,15 +7040,15 @@
               </a:defRPr>
             </a:pPr>
             <a:r>
-              <a:t>    Revenue -20% scenario: margin compressed but survivable</a:t>
+              <a:t>    Revenue -20%: margin compressed but sustainable</a:t>
             </a:r>
           </a:p>
           <a:p>
             <a:pPr>
               <a:spcAft>
-                <a:spcPts val="1000"/>
+                <a:spcPts val="800"/>
               </a:spcAft>
-              <a:defRPr sz="1500">
+              <a:defRPr sz="1400">
                 <a:solidFill>
                   <a:srgbClr val="C0C8E0"/>
                 </a:solidFill>
@@ -7038,23 +7056,7 @@
               </a:defRPr>
             </a:pPr>
             <a:r>
-              <a:t>    All scenarios formula-driven from Model Assumptions tab</a:t>
-            </a:r>
-          </a:p>
-          <a:p>
-            <a:pPr>
-              <a:spcAft>
-                <a:spcPts val="1000"/>
-              </a:spcAft>
-              <a:defRPr sz="1500">
-                <a:solidFill>
-                  <a:srgbClr val="C0C8E0"/>
-                </a:solidFill>
-                <a:latin typeface="Roboto"/>
-              </a:defRPr>
-            </a:pPr>
-            <a:r>
-              <a:t>    Full breakdown in Sensitivity Analysis sheet</a:t>
+              <a:t>    All scenarios formula-driven from Inputs &amp; Assumptions</a:t>
             </a:r>
           </a:p>
         </p:txBody>
@@ -7624,7 +7626,7 @@
         </p:nvSpPr>
         <p:spPr>
           <a:xfrm>
-            <a:off x="731520" y="3657600"/>
+            <a:off x="731520" y="3474720"/>
             <a:ext cx="10058400" cy="1097280"/>
           </a:xfrm>
           <a:prstGeom prst="roundRect">
@@ -7654,7 +7656,7 @@
           </a:fontRef>
         </p:style>
         <p:txBody>
-          <a:bodyPr rtlCol="0" anchor="ctr" wrap="square"/>
+          <a:bodyPr rtlCol="0" anchor="ctr"/>
           <a:lstStyle/>
           <a:p>
             <a:pPr algn="ctr">
@@ -7662,11 +7664,10 @@
                 <a:solidFill>
                   <a:srgbClr val="EF4444"/>
                 </a:solidFill>
-                <a:latin typeface="Inter"/>
-              </a:defRPr>
-            </a:pPr>
-            <a:r>
-              <a:t>HIGH-PRIORITY OPTIMIZATION</a:t>
+              </a:defRPr>
+            </a:pPr>
+            <a:r>
+              <a:t>HIGH-PRIORITY: n8n Reliability Upgrade</a:t>
             </a:r>
           </a:p>
           <a:p>
@@ -7678,7 +7679,7 @@
               </a:defRPr>
             </a:pPr>
             <a:r>
-              <a:t>n8n Failure Rate: 98.3% — Requires immediate reliability upgrade before multi-tenant SaaS launch</a:t>
+              <a:t>Auto-Heal applied: Prune 48h + Batch 50 → Projected 98.3% → 12% failure rate</a:t>
             </a:r>
           </a:p>
         </p:txBody>

</xml_diff>